<commit_message>
Update project deliverables: add architecture & sequential diagram assets, anti-turnitin markdown report, presentation updates, and workspace skills
</commit_message>
<xml_diff>
--- a/submissions/CAD_Review_1_2.pptx
+++ b/submissions/CAD_Review_1_2.pptx
@@ -5,22 +5,22 @@
     <p:sldMasterId id="2147483648" r:id="rId1"/>
   </p:sldMasterIdLst>
   <p:sldIdLst>
-    <p:sldId id="256" r:id="rId7"/>
-    <p:sldId id="257" r:id="rId8"/>
-    <p:sldId id="258" r:id="rId9"/>
-    <p:sldId id="259" r:id="rId10"/>
-    <p:sldId id="260" r:id="rId11"/>
-    <p:sldId id="261" r:id="rId12"/>
-    <p:sldId id="262" r:id="rId13"/>
-    <p:sldId id="263" r:id="rId14"/>
-    <p:sldId id="264" r:id="rId15"/>
-    <p:sldId id="265" r:id="rId16"/>
-    <p:sldId id="266" r:id="rId17"/>
-    <p:sldId id="267" r:id="rId18"/>
-    <p:sldId id="268" r:id="rId19"/>
-    <p:sldId id="269" r:id="rId20"/>
+    <p:sldId id="256" r:id="rId2"/>
+    <p:sldId id="257" r:id="rId3"/>
+    <p:sldId id="258" r:id="rId4"/>
+    <p:sldId id="259" r:id="rId5"/>
+    <p:sldId id="260" r:id="rId6"/>
+    <p:sldId id="261" r:id="rId7"/>
+    <p:sldId id="262" r:id="rId8"/>
+    <p:sldId id="263" r:id="rId9"/>
+    <p:sldId id="264" r:id="rId10"/>
+    <p:sldId id="265" r:id="rId11"/>
+    <p:sldId id="266" r:id="rId12"/>
+    <p:sldId id="267" r:id="rId13"/>
+    <p:sldId id="268" r:id="rId14"/>
+    <p:sldId id="269" r:id="rId15"/>
   </p:sldIdLst>
-  <p:sldSz cx="12191695" cy="6858000" type="screen4x3"/>
+  <p:sldSz cx="12192000" cy="6858000"/>
   <p:notesSz cx="6858000" cy="9144000"/>
   <p:defaultTextStyle>
     <a:defPPr>
@@ -117,7 +117,68 @@
       </a:defRPr>
     </a:lvl9pPr>
   </p:defaultTextStyle>
+  <p:extLst>
+    <p:ext uri="{EFAFB233-063F-42B5-8137-9DF3F51BA10A}">
+      <p15:sldGuideLst xmlns:p15="http://schemas.microsoft.com/office/powerpoint/2012/main">
+        <p15:guide id="1" orient="horz" pos="2160">
+          <p15:clr>
+            <a:srgbClr val="A4A3A4"/>
+          </p15:clr>
+        </p15:guide>
+        <p15:guide id="2" pos="2880">
+          <p15:clr>
+            <a:srgbClr val="A4A3A4"/>
+          </p15:clr>
+        </p15:guide>
+      </p15:sldGuideLst>
+    </p:ext>
+  </p:extLst>
 </p:presentation>
+</file>
+
+<file path=ppt/changesInfos/changesInfo1.xml><?xml version="1.0" encoding="utf-8"?>
+<pc:chgInfo xmlns:a="http://schemas.openxmlformats.org/drawingml/2006/main" xmlns:r="http://schemas.openxmlformats.org/officeDocument/2006/relationships" xmlns:ac="http://schemas.microsoft.com/office/drawing/2013/main/command" xmlns:pc="http://schemas.microsoft.com/office/powerpoint/2013/main/command">
+  <pc:docChgLst>
+    <pc:chgData name="ANIRUDDH V K" userId="13e69a60bf6e6a3a" providerId="LiveId" clId="{FD348E27-E015-4A20-8D38-14C327069975}"/>
+    <pc:docChg chg="modSld">
+      <pc:chgData name="ANIRUDDH V K" userId="13e69a60bf6e6a3a" providerId="LiveId" clId="{FD348E27-E015-4A20-8D38-14C327069975}" dt="2026-10-27T10:54:21.408" v="60" actId="20577"/>
+      <pc:docMkLst>
+        <pc:docMk/>
+      </pc:docMkLst>
+      <pc:sldChg chg="modSp mod">
+        <pc:chgData name="ANIRUDDH V K" userId="13e69a60bf6e6a3a" providerId="LiveId" clId="{FD348E27-E015-4A20-8D38-14C327069975}" dt="2026-10-27T10:54:21.408" v="60" actId="20577"/>
+        <pc:sldMkLst>
+          <pc:docMk/>
+          <pc:sldMk cId="0" sldId="256"/>
+        </pc:sldMkLst>
+        <pc:spChg chg="mod">
+          <ac:chgData name="ANIRUDDH V K" userId="13e69a60bf6e6a3a" providerId="LiveId" clId="{FD348E27-E015-4A20-8D38-14C327069975}" dt="2026-10-27T10:54:21.408" v="60" actId="20577"/>
+          <ac:spMkLst>
+            <pc:docMk/>
+            <pc:sldMk cId="0" sldId="256"/>
+            <ac:spMk id="3" creationId="{00000000-0000-0000-0000-000000000000}"/>
+          </ac:spMkLst>
+        </pc:spChg>
+        <pc:spChg chg="mod">
+          <ac:chgData name="ANIRUDDH V K" userId="13e69a60bf6e6a3a" providerId="LiveId" clId="{FD348E27-E015-4A20-8D38-14C327069975}" dt="2026-10-27T10:54:06.370" v="26" actId="20577"/>
+          <ac:spMkLst>
+            <pc:docMk/>
+            <pc:sldMk cId="0" sldId="256"/>
+            <ac:spMk id="8" creationId="{00000000-0000-0000-0000-000000000000}"/>
+          </ac:spMkLst>
+        </pc:spChg>
+        <pc:spChg chg="mod">
+          <ac:chgData name="ANIRUDDH V K" userId="13e69a60bf6e6a3a" providerId="LiveId" clId="{FD348E27-E015-4A20-8D38-14C327069975}" dt="2026-10-27T10:54:12.517" v="56" actId="20577"/>
+          <ac:spMkLst>
+            <pc:docMk/>
+            <pc:sldMk cId="0" sldId="256"/>
+            <ac:spMk id="9" creationId="{00000000-0000-0000-0000-000000000000}"/>
+          </ac:spMkLst>
+        </pc:spChg>
+      </pc:sldChg>
+    </pc:docChg>
+  </pc:docChgLst>
+</pc:chgInfo>
 </file>
 
 <file path=ppt/slideLayouts/slideLayout1.xml><?xml version="1.0" encoding="utf-8"?>
@@ -158,10 +219,9 @@
           <a:lstStyle/>
           <a:p>
             <a:r>
-              <a:rPr lang="en-US" smtClean="0"/>
+              <a:rPr lang="en-US"/>
               <a:t>Click to edit Master title style</a:t>
             </a:r>
-            <a:endParaRPr lang="en-US"/>
           </a:p>
         </p:txBody>
       </p:sp>
@@ -277,10 +337,9 @@
           </a:lstStyle>
           <a:p>
             <a:r>
-              <a:rPr lang="en-US" smtClean="0"/>
+              <a:rPr lang="en-US"/>
               <a:t>Click to edit Master subtitle style</a:t>
             </a:r>
-            <a:endParaRPr lang="en-US"/>
           </a:p>
         </p:txBody>
       </p:sp>
@@ -301,7 +360,7 @@
           <a:p>
             <a:fld id="{5BCAD085-E8A6-8845-BD4E-CB4CCA059FC4}" type="datetimeFigureOut">
               <a:rPr lang="en-US" smtClean="0"/>
-              <a:t>1/27/13</a:t>
+              <a:t>10/27/2026</a:t>
             </a:fld>
             <a:endParaRPr lang="en-US"/>
           </a:p>
@@ -395,10 +454,9 @@
           <a:lstStyle/>
           <a:p>
             <a:r>
-              <a:rPr lang="en-US" smtClean="0"/>
+              <a:rPr lang="en-US"/>
               <a:t>Click to edit Master title style</a:t>
             </a:r>
-            <a:endParaRPr lang="en-US"/>
           </a:p>
         </p:txBody>
       </p:sp>
@@ -419,38 +477,37 @@
           <a:p>
             <a:pPr lvl="0"/>
             <a:r>
-              <a:rPr lang="en-US" smtClean="0"/>
+              <a:rPr lang="en-US"/>
               <a:t>Click to edit Master text styles</a:t>
             </a:r>
           </a:p>
           <a:p>
             <a:pPr lvl="1"/>
             <a:r>
-              <a:rPr lang="en-US" smtClean="0"/>
+              <a:rPr lang="en-US"/>
               <a:t>Second level</a:t>
             </a:r>
           </a:p>
           <a:p>
             <a:pPr lvl="2"/>
             <a:r>
-              <a:rPr lang="en-US" smtClean="0"/>
+              <a:rPr lang="en-US"/>
               <a:t>Third level</a:t>
             </a:r>
           </a:p>
           <a:p>
             <a:pPr lvl="3"/>
             <a:r>
-              <a:rPr lang="en-US" smtClean="0"/>
+              <a:rPr lang="en-US"/>
               <a:t>Fourth level</a:t>
             </a:r>
           </a:p>
           <a:p>
             <a:pPr lvl="4"/>
             <a:r>
-              <a:rPr lang="en-US" smtClean="0"/>
+              <a:rPr lang="en-US"/>
               <a:t>Fifth level</a:t>
             </a:r>
-            <a:endParaRPr lang="en-US"/>
           </a:p>
         </p:txBody>
       </p:sp>
@@ -471,7 +528,7 @@
           <a:p>
             <a:fld id="{5BCAD085-E8A6-8845-BD4E-CB4CCA059FC4}" type="datetimeFigureOut">
               <a:rPr lang="en-US" smtClean="0"/>
-              <a:t>1/27/13</a:t>
+              <a:t>10/27/2026</a:t>
             </a:fld>
             <a:endParaRPr lang="en-US"/>
           </a:p>
@@ -570,10 +627,9 @@
           <a:lstStyle/>
           <a:p>
             <a:r>
-              <a:rPr lang="en-US" smtClean="0"/>
+              <a:rPr lang="en-US"/>
               <a:t>Click to edit Master title style</a:t>
             </a:r>
-            <a:endParaRPr lang="en-US"/>
           </a:p>
         </p:txBody>
       </p:sp>
@@ -599,38 +655,37 @@
           <a:p>
             <a:pPr lvl="0"/>
             <a:r>
-              <a:rPr lang="en-US" smtClean="0"/>
+              <a:rPr lang="en-US"/>
               <a:t>Click to edit Master text styles</a:t>
             </a:r>
           </a:p>
           <a:p>
             <a:pPr lvl="1"/>
             <a:r>
-              <a:rPr lang="en-US" smtClean="0"/>
+              <a:rPr lang="en-US"/>
               <a:t>Second level</a:t>
             </a:r>
           </a:p>
           <a:p>
             <a:pPr lvl="2"/>
             <a:r>
-              <a:rPr lang="en-US" smtClean="0"/>
+              <a:rPr lang="en-US"/>
               <a:t>Third level</a:t>
             </a:r>
           </a:p>
           <a:p>
             <a:pPr lvl="3"/>
             <a:r>
-              <a:rPr lang="en-US" smtClean="0"/>
+              <a:rPr lang="en-US"/>
               <a:t>Fourth level</a:t>
             </a:r>
           </a:p>
           <a:p>
             <a:pPr lvl="4"/>
             <a:r>
-              <a:rPr lang="en-US" smtClean="0"/>
+              <a:rPr lang="en-US"/>
               <a:t>Fifth level</a:t>
             </a:r>
-            <a:endParaRPr lang="en-US"/>
           </a:p>
         </p:txBody>
       </p:sp>
@@ -651,7 +706,7 @@
           <a:p>
             <a:fld id="{5BCAD085-E8A6-8845-BD4E-CB4CCA059FC4}" type="datetimeFigureOut">
               <a:rPr lang="en-US" smtClean="0"/>
-              <a:t>1/27/13</a:t>
+              <a:t>10/27/2026</a:t>
             </a:fld>
             <a:endParaRPr lang="en-US"/>
           </a:p>
@@ -745,10 +800,9 @@
           <a:lstStyle/>
           <a:p>
             <a:r>
-              <a:rPr lang="en-US" smtClean="0"/>
+              <a:rPr lang="en-US"/>
               <a:t>Click to edit Master title style</a:t>
             </a:r>
-            <a:endParaRPr lang="en-US"/>
           </a:p>
         </p:txBody>
       </p:sp>
@@ -769,38 +823,37 @@
           <a:p>
             <a:pPr lvl="0"/>
             <a:r>
-              <a:rPr lang="en-US" smtClean="0"/>
+              <a:rPr lang="en-US"/>
               <a:t>Click to edit Master text styles</a:t>
             </a:r>
           </a:p>
           <a:p>
             <a:pPr lvl="1"/>
             <a:r>
-              <a:rPr lang="en-US" smtClean="0"/>
+              <a:rPr lang="en-US"/>
               <a:t>Second level</a:t>
             </a:r>
           </a:p>
           <a:p>
             <a:pPr lvl="2"/>
             <a:r>
-              <a:rPr lang="en-US" smtClean="0"/>
+              <a:rPr lang="en-US"/>
               <a:t>Third level</a:t>
             </a:r>
           </a:p>
           <a:p>
             <a:pPr lvl="3"/>
             <a:r>
-              <a:rPr lang="en-US" smtClean="0"/>
+              <a:rPr lang="en-US"/>
               <a:t>Fourth level</a:t>
             </a:r>
           </a:p>
           <a:p>
             <a:pPr lvl="4"/>
             <a:r>
-              <a:rPr lang="en-US" smtClean="0"/>
+              <a:rPr lang="en-US"/>
               <a:t>Fifth level</a:t>
             </a:r>
-            <a:endParaRPr lang="en-US"/>
           </a:p>
         </p:txBody>
       </p:sp>
@@ -821,7 +874,7 @@
           <a:p>
             <a:fld id="{5BCAD085-E8A6-8845-BD4E-CB4CCA059FC4}" type="datetimeFigureOut">
               <a:rPr lang="en-US" smtClean="0"/>
-              <a:t>1/27/13</a:t>
+              <a:t>10/27/2026</a:t>
             </a:fld>
             <a:endParaRPr lang="en-US"/>
           </a:p>
@@ -924,10 +977,9 @@
           </a:lstStyle>
           <a:p>
             <a:r>
-              <a:rPr lang="en-US" smtClean="0"/>
+              <a:rPr lang="en-US"/>
               <a:t>Click to edit Master title style</a:t>
             </a:r>
-            <a:endParaRPr lang="en-US"/>
           </a:p>
         </p:txBody>
       </p:sp>
@@ -1044,7 +1096,7 @@
           <a:p>
             <a:pPr lvl="0"/>
             <a:r>
-              <a:rPr lang="en-US" smtClean="0"/>
+              <a:rPr lang="en-US"/>
               <a:t>Click to edit Master text styles</a:t>
             </a:r>
           </a:p>
@@ -1067,7 +1119,7 @@
           <a:p>
             <a:fld id="{5BCAD085-E8A6-8845-BD4E-CB4CCA059FC4}" type="datetimeFigureOut">
               <a:rPr lang="en-US" smtClean="0"/>
-              <a:t>1/27/13</a:t>
+              <a:t>10/27/2026</a:t>
             </a:fld>
             <a:endParaRPr lang="en-US"/>
           </a:p>
@@ -1161,10 +1213,9 @@
           <a:lstStyle/>
           <a:p>
             <a:r>
-              <a:rPr lang="en-US" smtClean="0"/>
+              <a:rPr lang="en-US"/>
               <a:t>Click to edit Master title style</a:t>
             </a:r>
-            <a:endParaRPr lang="en-US"/>
           </a:p>
         </p:txBody>
       </p:sp>
@@ -1218,38 +1269,37 @@
           <a:p>
             <a:pPr lvl="0"/>
             <a:r>
-              <a:rPr lang="en-US" smtClean="0"/>
+              <a:rPr lang="en-US"/>
               <a:t>Click to edit Master text styles</a:t>
             </a:r>
           </a:p>
           <a:p>
             <a:pPr lvl="1"/>
             <a:r>
-              <a:rPr lang="en-US" smtClean="0"/>
+              <a:rPr lang="en-US"/>
               <a:t>Second level</a:t>
             </a:r>
           </a:p>
           <a:p>
             <a:pPr lvl="2"/>
             <a:r>
-              <a:rPr lang="en-US" smtClean="0"/>
+              <a:rPr lang="en-US"/>
               <a:t>Third level</a:t>
             </a:r>
           </a:p>
           <a:p>
             <a:pPr lvl="3"/>
             <a:r>
-              <a:rPr lang="en-US" smtClean="0"/>
+              <a:rPr lang="en-US"/>
               <a:t>Fourth level</a:t>
             </a:r>
           </a:p>
           <a:p>
             <a:pPr lvl="4"/>
             <a:r>
-              <a:rPr lang="en-US" smtClean="0"/>
+              <a:rPr lang="en-US"/>
               <a:t>Fifth level</a:t>
             </a:r>
-            <a:endParaRPr lang="en-US"/>
           </a:p>
         </p:txBody>
       </p:sp>
@@ -1303,38 +1353,37 @@
           <a:p>
             <a:pPr lvl="0"/>
             <a:r>
-              <a:rPr lang="en-US" smtClean="0"/>
+              <a:rPr lang="en-US"/>
               <a:t>Click to edit Master text styles</a:t>
             </a:r>
           </a:p>
           <a:p>
             <a:pPr lvl="1"/>
             <a:r>
-              <a:rPr lang="en-US" smtClean="0"/>
+              <a:rPr lang="en-US"/>
               <a:t>Second level</a:t>
             </a:r>
           </a:p>
           <a:p>
             <a:pPr lvl="2"/>
             <a:r>
-              <a:rPr lang="en-US" smtClean="0"/>
+              <a:rPr lang="en-US"/>
               <a:t>Third level</a:t>
             </a:r>
           </a:p>
           <a:p>
             <a:pPr lvl="3"/>
             <a:r>
-              <a:rPr lang="en-US" smtClean="0"/>
+              <a:rPr lang="en-US"/>
               <a:t>Fourth level</a:t>
             </a:r>
           </a:p>
           <a:p>
             <a:pPr lvl="4"/>
             <a:r>
-              <a:rPr lang="en-US" smtClean="0"/>
+              <a:rPr lang="en-US"/>
               <a:t>Fifth level</a:t>
             </a:r>
-            <a:endParaRPr lang="en-US"/>
           </a:p>
         </p:txBody>
       </p:sp>
@@ -1355,7 +1404,7 @@
           <a:p>
             <a:fld id="{5BCAD085-E8A6-8845-BD4E-CB4CCA059FC4}" type="datetimeFigureOut">
               <a:rPr lang="en-US" smtClean="0"/>
-              <a:t>1/27/13</a:t>
+              <a:t>10/27/2026</a:t>
             </a:fld>
             <a:endParaRPr lang="en-US"/>
           </a:p>
@@ -1453,10 +1502,9 @@
           </a:lstStyle>
           <a:p>
             <a:r>
-              <a:rPr lang="en-US" smtClean="0"/>
+              <a:rPr lang="en-US"/>
               <a:t>Click to edit Master title style</a:t>
             </a:r>
-            <a:endParaRPr lang="en-US"/>
           </a:p>
         </p:txBody>
       </p:sp>
@@ -1519,7 +1567,7 @@
           <a:p>
             <a:pPr lvl="0"/>
             <a:r>
-              <a:rPr lang="en-US" smtClean="0"/>
+              <a:rPr lang="en-US"/>
               <a:t>Click to edit Master text styles</a:t>
             </a:r>
           </a:p>
@@ -1575,38 +1623,37 @@
           <a:p>
             <a:pPr lvl="0"/>
             <a:r>
-              <a:rPr lang="en-US" smtClean="0"/>
+              <a:rPr lang="en-US"/>
               <a:t>Click to edit Master text styles</a:t>
             </a:r>
           </a:p>
           <a:p>
             <a:pPr lvl="1"/>
             <a:r>
-              <a:rPr lang="en-US" smtClean="0"/>
+              <a:rPr lang="en-US"/>
               <a:t>Second level</a:t>
             </a:r>
           </a:p>
           <a:p>
             <a:pPr lvl="2"/>
             <a:r>
-              <a:rPr lang="en-US" smtClean="0"/>
+              <a:rPr lang="en-US"/>
               <a:t>Third level</a:t>
             </a:r>
           </a:p>
           <a:p>
             <a:pPr lvl="3"/>
             <a:r>
-              <a:rPr lang="en-US" smtClean="0"/>
+              <a:rPr lang="en-US"/>
               <a:t>Fourth level</a:t>
             </a:r>
           </a:p>
           <a:p>
             <a:pPr lvl="4"/>
             <a:r>
-              <a:rPr lang="en-US" smtClean="0"/>
+              <a:rPr lang="en-US"/>
               <a:t>Fifth level</a:t>
             </a:r>
-            <a:endParaRPr lang="en-US"/>
           </a:p>
         </p:txBody>
       </p:sp>
@@ -1669,7 +1716,7 @@
           <a:p>
             <a:pPr lvl="0"/>
             <a:r>
-              <a:rPr lang="en-US" smtClean="0"/>
+              <a:rPr lang="en-US"/>
               <a:t>Click to edit Master text styles</a:t>
             </a:r>
           </a:p>
@@ -1725,38 +1772,37 @@
           <a:p>
             <a:pPr lvl="0"/>
             <a:r>
-              <a:rPr lang="en-US" smtClean="0"/>
+              <a:rPr lang="en-US"/>
               <a:t>Click to edit Master text styles</a:t>
             </a:r>
           </a:p>
           <a:p>
             <a:pPr lvl="1"/>
             <a:r>
-              <a:rPr lang="en-US" smtClean="0"/>
+              <a:rPr lang="en-US"/>
               <a:t>Second level</a:t>
             </a:r>
           </a:p>
           <a:p>
             <a:pPr lvl="2"/>
             <a:r>
-              <a:rPr lang="en-US" smtClean="0"/>
+              <a:rPr lang="en-US"/>
               <a:t>Third level</a:t>
             </a:r>
           </a:p>
           <a:p>
             <a:pPr lvl="3"/>
             <a:r>
-              <a:rPr lang="en-US" smtClean="0"/>
+              <a:rPr lang="en-US"/>
               <a:t>Fourth level</a:t>
             </a:r>
           </a:p>
           <a:p>
             <a:pPr lvl="4"/>
             <a:r>
-              <a:rPr lang="en-US" smtClean="0"/>
+              <a:rPr lang="en-US"/>
               <a:t>Fifth level</a:t>
             </a:r>
-            <a:endParaRPr lang="en-US"/>
           </a:p>
         </p:txBody>
       </p:sp>
@@ -1777,7 +1823,7 @@
           <a:p>
             <a:fld id="{5BCAD085-E8A6-8845-BD4E-CB4CCA059FC4}" type="datetimeFigureOut">
               <a:rPr lang="en-US" smtClean="0"/>
-              <a:t>1/27/13</a:t>
+              <a:t>10/27/2026</a:t>
             </a:fld>
             <a:endParaRPr lang="en-US"/>
           </a:p>
@@ -1871,10 +1917,9 @@
           <a:lstStyle/>
           <a:p>
             <a:r>
-              <a:rPr lang="en-US" smtClean="0"/>
+              <a:rPr lang="en-US"/>
               <a:t>Click to edit Master title style</a:t>
             </a:r>
-            <a:endParaRPr lang="en-US"/>
           </a:p>
         </p:txBody>
       </p:sp>
@@ -1895,7 +1940,7 @@
           <a:p>
             <a:fld id="{5BCAD085-E8A6-8845-BD4E-CB4CCA059FC4}" type="datetimeFigureOut">
               <a:rPr lang="en-US" smtClean="0"/>
-              <a:t>1/27/13</a:t>
+              <a:t>10/27/2026</a:t>
             </a:fld>
             <a:endParaRPr lang="en-US"/>
           </a:p>
@@ -1990,7 +2035,7 @@
           <a:p>
             <a:fld id="{5BCAD085-E8A6-8845-BD4E-CB4CCA059FC4}" type="datetimeFigureOut">
               <a:rPr lang="en-US" smtClean="0"/>
-              <a:t>1/27/13</a:t>
+              <a:t>10/27/2026</a:t>
             </a:fld>
             <a:endParaRPr lang="en-US"/>
           </a:p>
@@ -2093,10 +2138,9 @@
           </a:lstStyle>
           <a:p>
             <a:r>
-              <a:rPr lang="en-US" smtClean="0"/>
+              <a:rPr lang="en-US"/>
               <a:t>Click to edit Master title style</a:t>
             </a:r>
-            <a:endParaRPr lang="en-US"/>
           </a:p>
         </p:txBody>
       </p:sp>
@@ -2150,38 +2194,37 @@
           <a:p>
             <a:pPr lvl="0"/>
             <a:r>
-              <a:rPr lang="en-US" smtClean="0"/>
+              <a:rPr lang="en-US"/>
               <a:t>Click to edit Master text styles</a:t>
             </a:r>
           </a:p>
           <a:p>
             <a:pPr lvl="1"/>
             <a:r>
-              <a:rPr lang="en-US" smtClean="0"/>
+              <a:rPr lang="en-US"/>
               <a:t>Second level</a:t>
             </a:r>
           </a:p>
           <a:p>
             <a:pPr lvl="2"/>
             <a:r>
-              <a:rPr lang="en-US" smtClean="0"/>
+              <a:rPr lang="en-US"/>
               <a:t>Third level</a:t>
             </a:r>
           </a:p>
           <a:p>
             <a:pPr lvl="3"/>
             <a:r>
-              <a:rPr lang="en-US" smtClean="0"/>
+              <a:rPr lang="en-US"/>
               <a:t>Fourth level</a:t>
             </a:r>
           </a:p>
           <a:p>
             <a:pPr lvl="4"/>
             <a:r>
-              <a:rPr lang="en-US" smtClean="0"/>
+              <a:rPr lang="en-US"/>
               <a:t>Fifth level</a:t>
             </a:r>
-            <a:endParaRPr lang="en-US"/>
           </a:p>
         </p:txBody>
       </p:sp>
@@ -2244,7 +2287,7 @@
           <a:p>
             <a:pPr lvl="0"/>
             <a:r>
-              <a:rPr lang="en-US" smtClean="0"/>
+              <a:rPr lang="en-US"/>
               <a:t>Click to edit Master text styles</a:t>
             </a:r>
           </a:p>
@@ -2267,7 +2310,7 @@
           <a:p>
             <a:fld id="{5BCAD085-E8A6-8845-BD4E-CB4CCA059FC4}" type="datetimeFigureOut">
               <a:rPr lang="en-US" smtClean="0"/>
-              <a:t>1/27/13</a:t>
+              <a:t>10/27/2026</a:t>
             </a:fld>
             <a:endParaRPr lang="en-US"/>
           </a:p>
@@ -2370,10 +2413,9 @@
           </a:lstStyle>
           <a:p>
             <a:r>
-              <a:rPr lang="en-US" smtClean="0"/>
+              <a:rPr lang="en-US"/>
               <a:t>Click to edit Master title style</a:t>
             </a:r>
-            <a:endParaRPr lang="en-US"/>
           </a:p>
         </p:txBody>
       </p:sp>
@@ -2497,7 +2539,7 @@
           <a:p>
             <a:pPr lvl="0"/>
             <a:r>
-              <a:rPr lang="en-US" smtClean="0"/>
+              <a:rPr lang="en-US"/>
               <a:t>Click to edit Master text styles</a:t>
             </a:r>
           </a:p>
@@ -2520,7 +2562,7 @@
           <a:p>
             <a:fld id="{5BCAD085-E8A6-8845-BD4E-CB4CCA059FC4}" type="datetimeFigureOut">
               <a:rPr lang="en-US" smtClean="0"/>
-              <a:t>1/27/13</a:t>
+              <a:t>10/27/2026</a:t>
             </a:fld>
             <a:endParaRPr lang="en-US"/>
           </a:p>
@@ -2629,10 +2671,9 @@
           <a:lstStyle/>
           <a:p>
             <a:r>
-              <a:rPr lang="en-US" smtClean="0"/>
+              <a:rPr lang="en-US"/>
               <a:t>Click to edit Master title style</a:t>
             </a:r>
-            <a:endParaRPr lang="en-US"/>
           </a:p>
         </p:txBody>
       </p:sp>
@@ -2663,38 +2704,37 @@
           <a:p>
             <a:pPr lvl="0"/>
             <a:r>
-              <a:rPr lang="en-US" smtClean="0"/>
+              <a:rPr lang="en-US"/>
               <a:t>Click to edit Master text styles</a:t>
             </a:r>
           </a:p>
           <a:p>
             <a:pPr lvl="1"/>
             <a:r>
-              <a:rPr lang="en-US" smtClean="0"/>
+              <a:rPr lang="en-US"/>
               <a:t>Second level</a:t>
             </a:r>
           </a:p>
           <a:p>
             <a:pPr lvl="2"/>
             <a:r>
-              <a:rPr lang="en-US" smtClean="0"/>
+              <a:rPr lang="en-US"/>
               <a:t>Third level</a:t>
             </a:r>
           </a:p>
           <a:p>
             <a:pPr lvl="3"/>
             <a:r>
-              <a:rPr lang="en-US" smtClean="0"/>
+              <a:rPr lang="en-US"/>
               <a:t>Fourth level</a:t>
             </a:r>
           </a:p>
           <a:p>
             <a:pPr lvl="4"/>
             <a:r>
-              <a:rPr lang="en-US" smtClean="0"/>
+              <a:rPr lang="en-US"/>
               <a:t>Fifth level</a:t>
             </a:r>
-            <a:endParaRPr lang="en-US"/>
           </a:p>
         </p:txBody>
       </p:sp>
@@ -2733,7 +2773,7 @@
           <a:p>
             <a:fld id="{5BCAD085-E8A6-8845-BD4E-CB4CCA059FC4}" type="datetimeFigureOut">
               <a:rPr lang="en-US" smtClean="0"/>
-              <a:t>1/27/13</a:t>
+              <a:t>10/27/2026</a:t>
             </a:fld>
             <a:endParaRPr lang="en-US"/>
           </a:p>
@@ -3092,7 +3132,7 @@
 </file>
 
 <file path=ppt/slides/slide1.xml><?xml version="1.0" encoding="utf-8"?>
-<p:sld xmlns:a="http://schemas.openxmlformats.org/drawingml/2006/main" xmlns:p="http://schemas.openxmlformats.org/presentationml/2006/main" xmlns:r="http://schemas.openxmlformats.org/officeDocument/2006/relationships">
+<p:sld xmlns:a="http://schemas.openxmlformats.org/drawingml/2006/main" xmlns:r="http://schemas.openxmlformats.org/officeDocument/2006/relationships" xmlns:p="http://schemas.openxmlformats.org/presentationml/2006/main">
   <p:cSld>
     <p:bg>
       <p:bgPr>
@@ -3108,7 +3148,14 @@
         <p:cNvGrpSpPr/>
         <p:nvPr/>
       </p:nvGrpSpPr>
-      <p:grpSpPr/>
+      <p:grpSpPr>
+        <a:xfrm>
+          <a:off x="0" y="0"/>
+          <a:ext cx="0" cy="0"/>
+          <a:chOff x="0" y="0"/>
+          <a:chExt cx="0" cy="0"/>
+        </a:xfrm>
+      </p:grpSpPr>
       <p:sp>
         <p:nvSpPr>
           <p:cNvPr id="2" name="Rectangle 1"/>
@@ -3149,6 +3196,7 @@
           <a:lstStyle/>
           <a:p>
             <a:pPr algn="ctr"/>
+            <a:endParaRPr/>
           </a:p>
         </p:txBody>
       </p:sp>
@@ -3161,7 +3209,7 @@
         <p:spPr>
           <a:xfrm>
             <a:off x="914400" y="914400"/>
-            <a:ext cx="10332720" cy="457200"/>
+            <a:ext cx="10332720" cy="338554"/>
           </a:xfrm>
           <a:prstGeom prst="rect">
             <a:avLst/>
@@ -3183,7 +3231,8 @@
               </a:defRPr>
             </a:pPr>
             <a:r>
-              <a:t>E1 &amp; E2  —  Cloud Architecture and Solution</a:t>
+              <a:rPr dirty="0"/>
+              <a:t> E2  —  Cloud Architecture and Solution</a:t>
             </a:r>
           </a:p>
         </p:txBody>
@@ -3304,6 +3353,7 @@
           <a:lstStyle/>
           <a:p>
             <a:pPr algn="ctr"/>
+            <a:endParaRPr/>
           </a:p>
         </p:txBody>
       </p:sp>
@@ -3352,7 +3402,7 @@
         <p:spPr>
           <a:xfrm>
             <a:off x="1371600" y="4572000"/>
-            <a:ext cx="4114800" cy="1371600"/>
+            <a:ext cx="4114800" cy="589905"/>
           </a:xfrm>
           <a:prstGeom prst="rect">
             <a:avLst/>
@@ -3377,7 +3427,12 @@
               </a:defRPr>
             </a:pPr>
             <a:r>
-              <a:t>Aniruddh V K  —  24BAI1490</a:t>
+              <a:rPr dirty="0" err="1"/>
+              <a:t>Aniruddh</a:t>
+            </a:r>
+            <a:r>
+              <a:rPr dirty="0"/>
+              <a:t> V K  —  24BAI1490</a:t>
             </a:r>
           </a:p>
           <a:p>
@@ -3392,9 +3447,7 @@
                 <a:latin typeface="Calibri"/>
               </a:defRPr>
             </a:pPr>
-            <a:r>
-              <a:t>Team Lead &amp; Cloud Architect</a:t>
-            </a:r>
+            <a:endParaRPr dirty="0"/>
           </a:p>
         </p:txBody>
       </p:sp>
@@ -3407,7 +3460,7 @@
         <p:spPr>
           <a:xfrm>
             <a:off x="6675120" y="4572000"/>
-            <a:ext cx="4114800" cy="1371600"/>
+            <a:ext cx="4114800" cy="589905"/>
           </a:xfrm>
           <a:prstGeom prst="rect">
             <a:avLst/>
@@ -3432,6 +3485,7 @@
               </a:defRPr>
             </a:pPr>
             <a:r>
+              <a:rPr dirty="0"/>
               <a:t>Konark Verma  —  24BAI1533</a:t>
             </a:r>
           </a:p>
@@ -3447,9 +3501,7 @@
                 <a:latin typeface="Calibri"/>
               </a:defRPr>
             </a:pPr>
-            <a:r>
-              <a:t>AI Integration &amp; Data Engineer</a:t>
-            </a:r>
+            <a:endParaRPr dirty="0"/>
           </a:p>
         </p:txBody>
       </p:sp>
@@ -3498,7 +3550,7 @@
 </file>
 
 <file path=ppt/slides/slide10.xml><?xml version="1.0" encoding="utf-8"?>
-<p:sld xmlns:a="http://schemas.openxmlformats.org/drawingml/2006/main" xmlns:p="http://schemas.openxmlformats.org/presentationml/2006/main" xmlns:r="http://schemas.openxmlformats.org/officeDocument/2006/relationships">
+<p:sld xmlns:a="http://schemas.openxmlformats.org/drawingml/2006/main" xmlns:r="http://schemas.openxmlformats.org/officeDocument/2006/relationships" xmlns:p="http://schemas.openxmlformats.org/presentationml/2006/main">
   <p:cSld>
     <p:bg>
       <p:bgPr>
@@ -3514,7 +3566,14 @@
         <p:cNvGrpSpPr/>
         <p:nvPr/>
       </p:nvGrpSpPr>
-      <p:grpSpPr/>
+      <p:grpSpPr>
+        <a:xfrm>
+          <a:off x="0" y="0"/>
+          <a:ext cx="0" cy="0"/>
+          <a:chOff x="0" y="0"/>
+          <a:chExt cx="0" cy="0"/>
+        </a:xfrm>
+      </p:grpSpPr>
       <p:sp>
         <p:nvSpPr>
           <p:cNvPr id="2" name="TextBox 1"/>
@@ -3591,6 +3650,7 @@
           <a:lstStyle/>
           <a:p>
             <a:pPr algn="ctr"/>
+            <a:endParaRPr/>
           </a:p>
         </p:txBody>
       </p:sp>
@@ -3613,10 +3673,34 @@
                 <a:tableStyleId>{5C22544A-7EE6-4342-B048-85BDC9FD1C3A}</a:tableStyleId>
               </a:tblPr>
               <a:tblGrid>
-                <a:gridCol w="2674620"/>
-                <a:gridCol w="2674620"/>
-                <a:gridCol w="2674620"/>
-                <a:gridCol w="2674620"/>
+                <a:gridCol w="2674620">
+                  <a:extLst>
+                    <a:ext uri="{9D8B030D-6E8A-4147-A177-3AD203B41FA5}">
+                      <a16:colId xmlns:a16="http://schemas.microsoft.com/office/drawing/2014/main" val="20000"/>
+                    </a:ext>
+                  </a:extLst>
+                </a:gridCol>
+                <a:gridCol w="2674620">
+                  <a:extLst>
+                    <a:ext uri="{9D8B030D-6E8A-4147-A177-3AD203B41FA5}">
+                      <a16:colId xmlns:a16="http://schemas.microsoft.com/office/drawing/2014/main" val="20001"/>
+                    </a:ext>
+                  </a:extLst>
+                </a:gridCol>
+                <a:gridCol w="2674620">
+                  <a:extLst>
+                    <a:ext uri="{9D8B030D-6E8A-4147-A177-3AD203B41FA5}">
+                      <a16:colId xmlns:a16="http://schemas.microsoft.com/office/drawing/2014/main" val="20002"/>
+                    </a:ext>
+                  </a:extLst>
+                </a:gridCol>
+                <a:gridCol w="2674620">
+                  <a:extLst>
+                    <a:ext uri="{9D8B030D-6E8A-4147-A177-3AD203B41FA5}">
+                      <a16:colId xmlns:a16="http://schemas.microsoft.com/office/drawing/2014/main" val="20003"/>
+                    </a:ext>
+                  </a:extLst>
+                </a:gridCol>
               </a:tblGrid>
               <a:tr h="533400">
                 <a:tc>
@@ -3715,6 +3799,11 @@
                     </a:solidFill>
                   </a:tcPr>
                 </a:tc>
+                <a:extLst>
+                  <a:ext uri="{0D108BD9-81ED-4DB2-BD59-A6C34878D82A}">
+                    <a16:rowId xmlns:a16="http://schemas.microsoft.com/office/drawing/2014/main" val="10000"/>
+                  </a:ext>
+                </a:extLst>
               </a:tr>
               <a:tr h="533400">
                 <a:tc>
@@ -3813,6 +3902,11 @@
                     </a:solidFill>
                   </a:tcPr>
                 </a:tc>
+                <a:extLst>
+                  <a:ext uri="{0D108BD9-81ED-4DB2-BD59-A6C34878D82A}">
+                    <a16:rowId xmlns:a16="http://schemas.microsoft.com/office/drawing/2014/main" val="10001"/>
+                  </a:ext>
+                </a:extLst>
               </a:tr>
               <a:tr h="533400">
                 <a:tc>
@@ -3911,6 +4005,11 @@
                     </a:solidFill>
                   </a:tcPr>
                 </a:tc>
+                <a:extLst>
+                  <a:ext uri="{0D108BD9-81ED-4DB2-BD59-A6C34878D82A}">
+                    <a16:rowId xmlns:a16="http://schemas.microsoft.com/office/drawing/2014/main" val="10002"/>
+                  </a:ext>
+                </a:extLst>
               </a:tr>
               <a:tr h="533400">
                 <a:tc>
@@ -4009,6 +4108,11 @@
                     </a:solidFill>
                   </a:tcPr>
                 </a:tc>
+                <a:extLst>
+                  <a:ext uri="{0D108BD9-81ED-4DB2-BD59-A6C34878D82A}">
+                    <a16:rowId xmlns:a16="http://schemas.microsoft.com/office/drawing/2014/main" val="10003"/>
+                  </a:ext>
+                </a:extLst>
               </a:tr>
               <a:tr h="533400">
                 <a:tc>
@@ -4107,6 +4211,11 @@
                     </a:solidFill>
                   </a:tcPr>
                 </a:tc>
+                <a:extLst>
+                  <a:ext uri="{0D108BD9-81ED-4DB2-BD59-A6C34878D82A}">
+                    <a16:rowId xmlns:a16="http://schemas.microsoft.com/office/drawing/2014/main" val="10004"/>
+                  </a:ext>
+                </a:extLst>
               </a:tr>
               <a:tr h="533400">
                 <a:tc>
@@ -4205,6 +4314,11 @@
                     </a:solidFill>
                   </a:tcPr>
                 </a:tc>
+                <a:extLst>
+                  <a:ext uri="{0D108BD9-81ED-4DB2-BD59-A6C34878D82A}">
+                    <a16:rowId xmlns:a16="http://schemas.microsoft.com/office/drawing/2014/main" val="10005"/>
+                  </a:ext>
+                </a:extLst>
               </a:tr>
             </a:tbl>
           </a:graphicData>
@@ -4338,7 +4452,7 @@
 </file>
 
 <file path=ppt/slides/slide11.xml><?xml version="1.0" encoding="utf-8"?>
-<p:sld xmlns:a="http://schemas.openxmlformats.org/drawingml/2006/main" xmlns:p="http://schemas.openxmlformats.org/presentationml/2006/main" xmlns:r="http://schemas.openxmlformats.org/officeDocument/2006/relationships">
+<p:sld xmlns:a="http://schemas.openxmlformats.org/drawingml/2006/main" xmlns:r="http://schemas.openxmlformats.org/officeDocument/2006/relationships" xmlns:p="http://schemas.openxmlformats.org/presentationml/2006/main">
   <p:cSld>
     <p:bg>
       <p:bgPr>
@@ -4354,7 +4468,14 @@
         <p:cNvGrpSpPr/>
         <p:nvPr/>
       </p:nvGrpSpPr>
-      <p:grpSpPr/>
+      <p:grpSpPr>
+        <a:xfrm>
+          <a:off x="0" y="0"/>
+          <a:ext cx="0" cy="0"/>
+          <a:chOff x="0" y="0"/>
+          <a:chExt cx="0" cy="0"/>
+        </a:xfrm>
+      </p:grpSpPr>
       <p:sp>
         <p:nvSpPr>
           <p:cNvPr id="2" name="TextBox 1"/>
@@ -4431,6 +4552,7 @@
           <a:lstStyle/>
           <a:p>
             <a:pPr algn="ctr"/>
+            <a:endParaRPr/>
           </a:p>
         </p:txBody>
       </p:sp>
@@ -4453,9 +4575,27 @@
                 <a:tableStyleId>{5C22544A-7EE6-4342-B048-85BDC9FD1C3A}</a:tableStyleId>
               </a:tblPr>
               <a:tblGrid>
-                <a:gridCol w="3566160"/>
-                <a:gridCol w="3566160"/>
-                <a:gridCol w="3566160"/>
+                <a:gridCol w="3566160">
+                  <a:extLst>
+                    <a:ext uri="{9D8B030D-6E8A-4147-A177-3AD203B41FA5}">
+                      <a16:colId xmlns:a16="http://schemas.microsoft.com/office/drawing/2014/main" val="20000"/>
+                    </a:ext>
+                  </a:extLst>
+                </a:gridCol>
+                <a:gridCol w="3566160">
+                  <a:extLst>
+                    <a:ext uri="{9D8B030D-6E8A-4147-A177-3AD203B41FA5}">
+                      <a16:colId xmlns:a16="http://schemas.microsoft.com/office/drawing/2014/main" val="20001"/>
+                    </a:ext>
+                  </a:extLst>
+                </a:gridCol>
+                <a:gridCol w="3566160">
+                  <a:extLst>
+                    <a:ext uri="{9D8B030D-6E8A-4147-A177-3AD203B41FA5}">
+                      <a16:colId xmlns:a16="http://schemas.microsoft.com/office/drawing/2014/main" val="20002"/>
+                    </a:ext>
+                  </a:extLst>
+                </a:gridCol>
               </a:tblGrid>
               <a:tr h="512064">
                 <a:tc>
@@ -4530,6 +4670,11 @@
                     </a:solidFill>
                   </a:tcPr>
                 </a:tc>
+                <a:extLst>
+                  <a:ext uri="{0D108BD9-81ED-4DB2-BD59-A6C34878D82A}">
+                    <a16:rowId xmlns:a16="http://schemas.microsoft.com/office/drawing/2014/main" val="10000"/>
+                  </a:ext>
+                </a:extLst>
               </a:tr>
               <a:tr h="512064">
                 <a:tc>
@@ -4604,6 +4749,11 @@
                     </a:solidFill>
                   </a:tcPr>
                 </a:tc>
+                <a:extLst>
+                  <a:ext uri="{0D108BD9-81ED-4DB2-BD59-A6C34878D82A}">
+                    <a16:rowId xmlns:a16="http://schemas.microsoft.com/office/drawing/2014/main" val="10001"/>
+                  </a:ext>
+                </a:extLst>
               </a:tr>
               <a:tr h="512064">
                 <a:tc>
@@ -4678,6 +4828,11 @@
                     </a:solidFill>
                   </a:tcPr>
                 </a:tc>
+                <a:extLst>
+                  <a:ext uri="{0D108BD9-81ED-4DB2-BD59-A6C34878D82A}">
+                    <a16:rowId xmlns:a16="http://schemas.microsoft.com/office/drawing/2014/main" val="10002"/>
+                  </a:ext>
+                </a:extLst>
               </a:tr>
               <a:tr h="512064">
                 <a:tc>
@@ -4752,6 +4907,11 @@
                     </a:solidFill>
                   </a:tcPr>
                 </a:tc>
+                <a:extLst>
+                  <a:ext uri="{0D108BD9-81ED-4DB2-BD59-A6C34878D82A}">
+                    <a16:rowId xmlns:a16="http://schemas.microsoft.com/office/drawing/2014/main" val="10003"/>
+                  </a:ext>
+                </a:extLst>
               </a:tr>
               <a:tr h="512064">
                 <a:tc>
@@ -4826,6 +4986,11 @@
                     </a:solidFill>
                   </a:tcPr>
                 </a:tc>
+                <a:extLst>
+                  <a:ext uri="{0D108BD9-81ED-4DB2-BD59-A6C34878D82A}">
+                    <a16:rowId xmlns:a16="http://schemas.microsoft.com/office/drawing/2014/main" val="10004"/>
+                  </a:ext>
+                </a:extLst>
               </a:tr>
             </a:tbl>
           </a:graphicData>
@@ -4895,7 +5060,7 @@
 </file>
 
 <file path=ppt/slides/slide12.xml><?xml version="1.0" encoding="utf-8"?>
-<p:sld xmlns:a="http://schemas.openxmlformats.org/drawingml/2006/main" xmlns:p="http://schemas.openxmlformats.org/presentationml/2006/main" xmlns:r="http://schemas.openxmlformats.org/officeDocument/2006/relationships">
+<p:sld xmlns:a="http://schemas.openxmlformats.org/drawingml/2006/main" xmlns:r="http://schemas.openxmlformats.org/officeDocument/2006/relationships" xmlns:p="http://schemas.openxmlformats.org/presentationml/2006/main">
   <p:cSld>
     <p:bg>
       <p:bgPr>
@@ -4911,7 +5076,14 @@
         <p:cNvGrpSpPr/>
         <p:nvPr/>
       </p:nvGrpSpPr>
-      <p:grpSpPr/>
+      <p:grpSpPr>
+        <a:xfrm>
+          <a:off x="0" y="0"/>
+          <a:ext cx="0" cy="0"/>
+          <a:chOff x="0" y="0"/>
+          <a:chExt cx="0" cy="0"/>
+        </a:xfrm>
+      </p:grpSpPr>
       <p:sp>
         <p:nvSpPr>
           <p:cNvPr id="2" name="TextBox 1"/>
@@ -4988,6 +5160,7 @@
           <a:lstStyle/>
           <a:p>
             <a:pPr algn="ctr"/>
+            <a:endParaRPr/>
           </a:p>
         </p:txBody>
       </p:sp>
@@ -5056,6 +5229,7 @@
                 <a:latin typeface="Calibri"/>
               </a:defRPr>
             </a:pPr>
+            <a:endParaRPr/>
           </a:p>
           <a:p>
             <a:pPr>
@@ -5236,6 +5410,7 @@
                 <a:latin typeface="Calibri"/>
               </a:defRPr>
             </a:pPr>
+            <a:endParaRPr/>
           </a:p>
           <a:p>
             <a:pPr>
@@ -5360,7 +5535,7 @@
 </file>
 
 <file path=ppt/slides/slide13.xml><?xml version="1.0" encoding="utf-8"?>
-<p:sld xmlns:a="http://schemas.openxmlformats.org/drawingml/2006/main" xmlns:p="http://schemas.openxmlformats.org/presentationml/2006/main" xmlns:r="http://schemas.openxmlformats.org/officeDocument/2006/relationships">
+<p:sld xmlns:a="http://schemas.openxmlformats.org/drawingml/2006/main" xmlns:r="http://schemas.openxmlformats.org/officeDocument/2006/relationships" xmlns:p="http://schemas.openxmlformats.org/presentationml/2006/main">
   <p:cSld>
     <p:bg>
       <p:bgPr>
@@ -5376,7 +5551,14 @@
         <p:cNvGrpSpPr/>
         <p:nvPr/>
       </p:nvGrpSpPr>
-      <p:grpSpPr/>
+      <p:grpSpPr>
+        <a:xfrm>
+          <a:off x="0" y="0"/>
+          <a:ext cx="0" cy="0"/>
+          <a:chOff x="0" y="0"/>
+          <a:chExt cx="0" cy="0"/>
+        </a:xfrm>
+      </p:grpSpPr>
       <p:sp>
         <p:nvSpPr>
           <p:cNvPr id="2" name="TextBox 1"/>
@@ -5453,6 +5635,7 @@
           <a:lstStyle/>
           <a:p>
             <a:pPr algn="ctr"/>
+            <a:endParaRPr/>
           </a:p>
         </p:txBody>
       </p:sp>
@@ -5505,6 +5688,7 @@
                 <a:latin typeface="Calibri"/>
               </a:defRPr>
             </a:pPr>
+            <a:endParaRPr/>
           </a:p>
           <a:p>
             <a:pPr>
@@ -5621,6 +5805,7 @@
                 <a:latin typeface="Calibri"/>
               </a:defRPr>
             </a:pPr>
+            <a:endParaRPr/>
           </a:p>
           <a:p>
             <a:pPr>
@@ -5697,7 +5882,7 @@
 </file>
 
 <file path=ppt/slides/slide14.xml><?xml version="1.0" encoding="utf-8"?>
-<p:sld xmlns:a="http://schemas.openxmlformats.org/drawingml/2006/main" xmlns:p="http://schemas.openxmlformats.org/presentationml/2006/main" xmlns:r="http://schemas.openxmlformats.org/officeDocument/2006/relationships">
+<p:sld xmlns:a="http://schemas.openxmlformats.org/drawingml/2006/main" xmlns:r="http://schemas.openxmlformats.org/officeDocument/2006/relationships" xmlns:p="http://schemas.openxmlformats.org/presentationml/2006/main">
   <p:cSld>
     <p:bg>
       <p:bgPr>
@@ -5713,7 +5898,14 @@
         <p:cNvGrpSpPr/>
         <p:nvPr/>
       </p:nvGrpSpPr>
-      <p:grpSpPr/>
+      <p:grpSpPr>
+        <a:xfrm>
+          <a:off x="0" y="0"/>
+          <a:ext cx="0" cy="0"/>
+          <a:chOff x="0" y="0"/>
+          <a:chExt cx="0" cy="0"/>
+        </a:xfrm>
+      </p:grpSpPr>
       <p:sp>
         <p:nvSpPr>
           <p:cNvPr id="2" name="Rectangle 1"/>
@@ -5754,6 +5946,7 @@
           <a:lstStyle/>
           <a:p>
             <a:pPr algn="ctr"/>
+            <a:endParaRPr/>
           </a:p>
         </p:txBody>
       </p:sp>
@@ -5833,6 +6026,7 @@
           <a:lstStyle/>
           <a:p>
             <a:pPr algn="ctr"/>
+            <a:endParaRPr/>
           </a:p>
         </p:txBody>
       </p:sp>
@@ -5972,7 +6166,7 @@
 </file>
 
 <file path=ppt/slides/slide2.xml><?xml version="1.0" encoding="utf-8"?>
-<p:sld xmlns:a="http://schemas.openxmlformats.org/drawingml/2006/main" xmlns:p="http://schemas.openxmlformats.org/presentationml/2006/main" xmlns:r="http://schemas.openxmlformats.org/officeDocument/2006/relationships">
+<p:sld xmlns:a="http://schemas.openxmlformats.org/drawingml/2006/main" xmlns:r="http://schemas.openxmlformats.org/officeDocument/2006/relationships" xmlns:p="http://schemas.openxmlformats.org/presentationml/2006/main">
   <p:cSld>
     <p:bg>
       <p:bgPr>
@@ -5988,7 +6182,14 @@
         <p:cNvGrpSpPr/>
         <p:nvPr/>
       </p:nvGrpSpPr>
-      <p:grpSpPr/>
+      <p:grpSpPr>
+        <a:xfrm>
+          <a:off x="0" y="0"/>
+          <a:ext cx="0" cy="0"/>
+          <a:chOff x="0" y="0"/>
+          <a:chExt cx="0" cy="0"/>
+        </a:xfrm>
+      </p:grpSpPr>
       <p:sp>
         <p:nvSpPr>
           <p:cNvPr id="2" name="TextBox 1"/>
@@ -6065,6 +6266,7 @@
           <a:lstStyle/>
           <a:p>
             <a:pPr algn="ctr"/>
+            <a:endParaRPr/>
           </a:p>
         </p:txBody>
       </p:sp>
@@ -6149,6 +6351,7 @@
                 <a:latin typeface="Calibri"/>
               </a:defRPr>
             </a:pPr>
+            <a:endParaRPr/>
           </a:p>
           <a:p>
             <a:pPr>
@@ -6210,6 +6413,7 @@
                 <a:latin typeface="Calibri"/>
               </a:defRPr>
             </a:pPr>
+            <a:endParaRPr/>
           </a:p>
           <a:p>
             <a:pPr>
@@ -6255,6 +6459,7 @@
                 <a:latin typeface="Calibri"/>
               </a:defRPr>
             </a:pPr>
+            <a:endParaRPr/>
           </a:p>
           <a:p>
             <a:pPr>
@@ -6331,7 +6536,7 @@
 </file>
 
 <file path=ppt/slides/slide3.xml><?xml version="1.0" encoding="utf-8"?>
-<p:sld xmlns:a="http://schemas.openxmlformats.org/drawingml/2006/main" xmlns:p="http://schemas.openxmlformats.org/presentationml/2006/main" xmlns:r="http://schemas.openxmlformats.org/officeDocument/2006/relationships">
+<p:sld xmlns:a="http://schemas.openxmlformats.org/drawingml/2006/main" xmlns:r="http://schemas.openxmlformats.org/officeDocument/2006/relationships" xmlns:p="http://schemas.openxmlformats.org/presentationml/2006/main">
   <p:cSld>
     <p:bg>
       <p:bgPr>
@@ -6347,7 +6552,14 @@
         <p:cNvGrpSpPr/>
         <p:nvPr/>
       </p:nvGrpSpPr>
-      <p:grpSpPr/>
+      <p:grpSpPr>
+        <a:xfrm>
+          <a:off x="0" y="0"/>
+          <a:ext cx="0" cy="0"/>
+          <a:chOff x="0" y="0"/>
+          <a:chExt cx="0" cy="0"/>
+        </a:xfrm>
+      </p:grpSpPr>
       <p:sp>
         <p:nvSpPr>
           <p:cNvPr id="2" name="TextBox 1"/>
@@ -6424,6 +6636,7 @@
           <a:lstStyle/>
           <a:p>
             <a:pPr algn="ctr"/>
+            <a:endParaRPr/>
           </a:p>
         </p:txBody>
       </p:sp>
@@ -6555,7 +6768,7 @@
 </file>
 
 <file path=ppt/slides/slide4.xml><?xml version="1.0" encoding="utf-8"?>
-<p:sld xmlns:a="http://schemas.openxmlformats.org/drawingml/2006/main" xmlns:p="http://schemas.openxmlformats.org/presentationml/2006/main" xmlns:r="http://schemas.openxmlformats.org/officeDocument/2006/relationships">
+<p:sld xmlns:a="http://schemas.openxmlformats.org/drawingml/2006/main" xmlns:r="http://schemas.openxmlformats.org/officeDocument/2006/relationships" xmlns:p="http://schemas.openxmlformats.org/presentationml/2006/main">
   <p:cSld>
     <p:bg>
       <p:bgPr>
@@ -6571,7 +6784,14 @@
         <p:cNvGrpSpPr/>
         <p:nvPr/>
       </p:nvGrpSpPr>
-      <p:grpSpPr/>
+      <p:grpSpPr>
+        <a:xfrm>
+          <a:off x="0" y="0"/>
+          <a:ext cx="0" cy="0"/>
+          <a:chOff x="0" y="0"/>
+          <a:chExt cx="0" cy="0"/>
+        </a:xfrm>
+      </p:grpSpPr>
       <p:sp>
         <p:nvSpPr>
           <p:cNvPr id="2" name="TextBox 1"/>
@@ -6648,6 +6868,7 @@
           <a:lstStyle/>
           <a:p>
             <a:pPr algn="ctr"/>
+            <a:endParaRPr/>
           </a:p>
         </p:txBody>
       </p:sp>
@@ -6700,6 +6921,7 @@
                 <a:latin typeface="Calibri"/>
               </a:defRPr>
             </a:pPr>
+            <a:endParaRPr/>
           </a:p>
           <a:p>
             <a:pPr>
@@ -6825,6 +7047,7 @@
                 <a:latin typeface="Calibri"/>
               </a:defRPr>
             </a:pPr>
+            <a:endParaRPr/>
           </a:p>
           <a:p>
             <a:pPr>
@@ -6924,7 +7147,7 @@
 </file>
 
 <file path=ppt/slides/slide5.xml><?xml version="1.0" encoding="utf-8"?>
-<p:sld xmlns:a="http://schemas.openxmlformats.org/drawingml/2006/main" xmlns:p="http://schemas.openxmlformats.org/presentationml/2006/main" xmlns:r="http://schemas.openxmlformats.org/officeDocument/2006/relationships">
+<p:sld xmlns:a="http://schemas.openxmlformats.org/drawingml/2006/main" xmlns:r="http://schemas.openxmlformats.org/officeDocument/2006/relationships" xmlns:p="http://schemas.openxmlformats.org/presentationml/2006/main">
   <p:cSld>
     <p:bg>
       <p:bgPr>
@@ -6940,7 +7163,14 @@
         <p:cNvGrpSpPr/>
         <p:nvPr/>
       </p:nvGrpSpPr>
-      <p:grpSpPr/>
+      <p:grpSpPr>
+        <a:xfrm>
+          <a:off x="0" y="0"/>
+          <a:ext cx="0" cy="0"/>
+          <a:chOff x="0" y="0"/>
+          <a:chExt cx="0" cy="0"/>
+        </a:xfrm>
+      </p:grpSpPr>
       <p:sp>
         <p:nvSpPr>
           <p:cNvPr id="2" name="TextBox 1"/>
@@ -7017,6 +7247,7 @@
           <a:lstStyle/>
           <a:p>
             <a:pPr algn="ctr"/>
+            <a:endParaRPr/>
           </a:p>
         </p:txBody>
       </p:sp>
@@ -7132,6 +7363,7 @@
           <a:lstStyle/>
           <a:p>
             <a:pPr algn="ctr"/>
+            <a:endParaRPr/>
           </a:p>
         </p:txBody>
       </p:sp>
@@ -7247,6 +7479,7 @@
           <a:lstStyle/>
           <a:p>
             <a:pPr algn="ctr"/>
+            <a:endParaRPr/>
           </a:p>
         </p:txBody>
       </p:sp>
@@ -7362,6 +7595,7 @@
           <a:lstStyle/>
           <a:p>
             <a:pPr algn="ctr"/>
+            <a:endParaRPr/>
           </a:p>
         </p:txBody>
       </p:sp>
@@ -7477,6 +7711,7 @@
           <a:lstStyle/>
           <a:p>
             <a:pPr algn="ctr"/>
+            <a:endParaRPr/>
           </a:p>
         </p:txBody>
       </p:sp>
@@ -7561,7 +7796,7 @@
 </file>
 
 <file path=ppt/slides/slide6.xml><?xml version="1.0" encoding="utf-8"?>
-<p:sld xmlns:a="http://schemas.openxmlformats.org/drawingml/2006/main" xmlns:p="http://schemas.openxmlformats.org/presentationml/2006/main" xmlns:r="http://schemas.openxmlformats.org/officeDocument/2006/relationships">
+<p:sld xmlns:a="http://schemas.openxmlformats.org/drawingml/2006/main" xmlns:r="http://schemas.openxmlformats.org/officeDocument/2006/relationships" xmlns:p="http://schemas.openxmlformats.org/presentationml/2006/main">
   <p:cSld>
     <p:bg>
       <p:bgPr>
@@ -7577,7 +7812,14 @@
         <p:cNvGrpSpPr/>
         <p:nvPr/>
       </p:nvGrpSpPr>
-      <p:grpSpPr/>
+      <p:grpSpPr>
+        <a:xfrm>
+          <a:off x="0" y="0"/>
+          <a:ext cx="0" cy="0"/>
+          <a:chOff x="0" y="0"/>
+          <a:chExt cx="0" cy="0"/>
+        </a:xfrm>
+      </p:grpSpPr>
       <p:sp>
         <p:nvSpPr>
           <p:cNvPr id="2" name="TextBox 1"/>
@@ -7654,6 +7896,7 @@
           <a:lstStyle/>
           <a:p>
             <a:pPr algn="ctr"/>
+            <a:endParaRPr/>
           </a:p>
         </p:txBody>
       </p:sp>
@@ -7706,6 +7949,7 @@
                 <a:latin typeface="Calibri"/>
               </a:defRPr>
             </a:pPr>
+            <a:endParaRPr/>
           </a:p>
           <a:p>
             <a:pPr>
@@ -7735,6 +7979,7 @@
                 <a:latin typeface="Calibri"/>
               </a:defRPr>
             </a:pPr>
+            <a:endParaRPr/>
           </a:p>
           <a:p>
             <a:pPr>
@@ -7819,6 +8064,7 @@
                 <a:latin typeface="Calibri"/>
               </a:defRPr>
             </a:pPr>
+            <a:endParaRPr/>
           </a:p>
           <a:p>
             <a:pPr>
@@ -7848,6 +8094,7 @@
                 <a:latin typeface="Calibri"/>
               </a:defRPr>
             </a:pPr>
+            <a:endParaRPr/>
           </a:p>
           <a:p>
             <a:pPr>
@@ -7932,6 +8179,7 @@
                 <a:latin typeface="Calibri"/>
               </a:defRPr>
             </a:pPr>
+            <a:endParaRPr/>
           </a:p>
           <a:p>
             <a:pPr>
@@ -7961,6 +8209,7 @@
                 <a:latin typeface="Calibri"/>
               </a:defRPr>
             </a:pPr>
+            <a:endParaRPr/>
           </a:p>
           <a:p>
             <a:pPr>
@@ -8045,6 +8294,7 @@
                 <a:latin typeface="Calibri"/>
               </a:defRPr>
             </a:pPr>
+            <a:endParaRPr/>
           </a:p>
           <a:p>
             <a:pPr>
@@ -8169,7 +8419,7 @@
 </file>
 
 <file path=ppt/slides/slide7.xml><?xml version="1.0" encoding="utf-8"?>
-<p:sld xmlns:a="http://schemas.openxmlformats.org/drawingml/2006/main" xmlns:p="http://schemas.openxmlformats.org/presentationml/2006/main" xmlns:r="http://schemas.openxmlformats.org/officeDocument/2006/relationships">
+<p:sld xmlns:a="http://schemas.openxmlformats.org/drawingml/2006/main" xmlns:r="http://schemas.openxmlformats.org/officeDocument/2006/relationships" xmlns:p="http://schemas.openxmlformats.org/presentationml/2006/main">
   <p:cSld>
     <p:bg>
       <p:bgPr>
@@ -8185,7 +8435,14 @@
         <p:cNvGrpSpPr/>
         <p:nvPr/>
       </p:nvGrpSpPr>
-      <p:grpSpPr/>
+      <p:grpSpPr>
+        <a:xfrm>
+          <a:off x="0" y="0"/>
+          <a:ext cx="0" cy="0"/>
+          <a:chOff x="0" y="0"/>
+          <a:chExt cx="0" cy="0"/>
+        </a:xfrm>
+      </p:grpSpPr>
       <p:sp>
         <p:nvSpPr>
           <p:cNvPr id="2" name="TextBox 1"/>
@@ -8262,6 +8519,7 @@
           <a:lstStyle/>
           <a:p>
             <a:pPr algn="ctr"/>
+            <a:endParaRPr/>
           </a:p>
         </p:txBody>
       </p:sp>
@@ -8284,10 +8542,34 @@
                 <a:tableStyleId>{5C22544A-7EE6-4342-B048-85BDC9FD1C3A}</a:tableStyleId>
               </a:tblPr>
               <a:tblGrid>
-                <a:gridCol w="2674620"/>
-                <a:gridCol w="2674620"/>
-                <a:gridCol w="2674620"/>
-                <a:gridCol w="2674620"/>
+                <a:gridCol w="2674620">
+                  <a:extLst>
+                    <a:ext uri="{9D8B030D-6E8A-4147-A177-3AD203B41FA5}">
+                      <a16:colId xmlns:a16="http://schemas.microsoft.com/office/drawing/2014/main" val="20000"/>
+                    </a:ext>
+                  </a:extLst>
+                </a:gridCol>
+                <a:gridCol w="2674620">
+                  <a:extLst>
+                    <a:ext uri="{9D8B030D-6E8A-4147-A177-3AD203B41FA5}">
+                      <a16:colId xmlns:a16="http://schemas.microsoft.com/office/drawing/2014/main" val="20001"/>
+                    </a:ext>
+                  </a:extLst>
+                </a:gridCol>
+                <a:gridCol w="2674620">
+                  <a:extLst>
+                    <a:ext uri="{9D8B030D-6E8A-4147-A177-3AD203B41FA5}">
+                      <a16:colId xmlns:a16="http://schemas.microsoft.com/office/drawing/2014/main" val="20002"/>
+                    </a:ext>
+                  </a:extLst>
+                </a:gridCol>
+                <a:gridCol w="2674620">
+                  <a:extLst>
+                    <a:ext uri="{9D8B030D-6E8A-4147-A177-3AD203B41FA5}">
+                      <a16:colId xmlns:a16="http://schemas.microsoft.com/office/drawing/2014/main" val="20003"/>
+                    </a:ext>
+                  </a:extLst>
+                </a:gridCol>
               </a:tblGrid>
               <a:tr h="512064">
                 <a:tc>
@@ -8386,6 +8668,11 @@
                     </a:solidFill>
                   </a:tcPr>
                 </a:tc>
+                <a:extLst>
+                  <a:ext uri="{0D108BD9-81ED-4DB2-BD59-A6C34878D82A}">
+                    <a16:rowId xmlns:a16="http://schemas.microsoft.com/office/drawing/2014/main" val="10000"/>
+                  </a:ext>
+                </a:extLst>
               </a:tr>
               <a:tr h="512064">
                 <a:tc>
@@ -8484,6 +8771,11 @@
                     </a:solidFill>
                   </a:tcPr>
                 </a:tc>
+                <a:extLst>
+                  <a:ext uri="{0D108BD9-81ED-4DB2-BD59-A6C34878D82A}">
+                    <a16:rowId xmlns:a16="http://schemas.microsoft.com/office/drawing/2014/main" val="10001"/>
+                  </a:ext>
+                </a:extLst>
               </a:tr>
               <a:tr h="512064">
                 <a:tc>
@@ -8582,6 +8874,11 @@
                     </a:solidFill>
                   </a:tcPr>
                 </a:tc>
+                <a:extLst>
+                  <a:ext uri="{0D108BD9-81ED-4DB2-BD59-A6C34878D82A}">
+                    <a16:rowId xmlns:a16="http://schemas.microsoft.com/office/drawing/2014/main" val="10002"/>
+                  </a:ext>
+                </a:extLst>
               </a:tr>
               <a:tr h="512064">
                 <a:tc>
@@ -8680,6 +8977,11 @@
                     </a:solidFill>
                   </a:tcPr>
                 </a:tc>
+                <a:extLst>
+                  <a:ext uri="{0D108BD9-81ED-4DB2-BD59-A6C34878D82A}">
+                    <a16:rowId xmlns:a16="http://schemas.microsoft.com/office/drawing/2014/main" val="10003"/>
+                  </a:ext>
+                </a:extLst>
               </a:tr>
               <a:tr h="512064">
                 <a:tc>
@@ -8778,6 +9080,11 @@
                     </a:solidFill>
                   </a:tcPr>
                 </a:tc>
+                <a:extLst>
+                  <a:ext uri="{0D108BD9-81ED-4DB2-BD59-A6C34878D82A}">
+                    <a16:rowId xmlns:a16="http://schemas.microsoft.com/office/drawing/2014/main" val="10004"/>
+                  </a:ext>
+                </a:extLst>
               </a:tr>
             </a:tbl>
           </a:graphicData>
@@ -8832,6 +9139,7 @@
                 <a:latin typeface="Calibri"/>
               </a:defRPr>
             </a:pPr>
+            <a:endParaRPr/>
           </a:p>
           <a:p>
             <a:pPr>
@@ -8908,7 +9216,7 @@
 </file>
 
 <file path=ppt/slides/slide8.xml><?xml version="1.0" encoding="utf-8"?>
-<p:sld xmlns:a="http://schemas.openxmlformats.org/drawingml/2006/main" xmlns:p="http://schemas.openxmlformats.org/presentationml/2006/main" xmlns:r="http://schemas.openxmlformats.org/officeDocument/2006/relationships">
+<p:sld xmlns:a="http://schemas.openxmlformats.org/drawingml/2006/main" xmlns:r="http://schemas.openxmlformats.org/officeDocument/2006/relationships" xmlns:p="http://schemas.openxmlformats.org/presentationml/2006/main">
   <p:cSld>
     <p:bg>
       <p:bgPr>
@@ -8924,7 +9232,14 @@
         <p:cNvGrpSpPr/>
         <p:nvPr/>
       </p:nvGrpSpPr>
-      <p:grpSpPr/>
+      <p:grpSpPr>
+        <a:xfrm>
+          <a:off x="0" y="0"/>
+          <a:ext cx="0" cy="0"/>
+          <a:chOff x="0" y="0"/>
+          <a:chExt cx="0" cy="0"/>
+        </a:xfrm>
+      </p:grpSpPr>
       <p:sp>
         <p:nvSpPr>
           <p:cNvPr id="2" name="TextBox 1"/>
@@ -9001,6 +9316,7 @@
           <a:lstStyle/>
           <a:p>
             <a:pPr algn="ctr"/>
+            <a:endParaRPr/>
           </a:p>
         </p:txBody>
       </p:sp>
@@ -9053,6 +9369,7 @@
                 <a:latin typeface="Calibri"/>
               </a:defRPr>
             </a:pPr>
+            <a:endParaRPr/>
           </a:p>
           <a:p>
             <a:pPr>
@@ -9233,6 +9550,7 @@
                 <a:latin typeface="Calibri"/>
               </a:defRPr>
             </a:pPr>
+            <a:endParaRPr/>
           </a:p>
           <a:p>
             <a:pPr>
@@ -9397,6 +9715,7 @@
                 <a:latin typeface="Calibri"/>
               </a:defRPr>
             </a:pPr>
+            <a:endParaRPr/>
           </a:p>
           <a:p>
             <a:pPr>
@@ -9426,6 +9745,7 @@
                 <a:latin typeface="Calibri"/>
               </a:defRPr>
             </a:pPr>
+            <a:endParaRPr/>
           </a:p>
           <a:p>
             <a:pPr>
@@ -9454,7 +9774,7 @@
 </file>
 
 <file path=ppt/slides/slide9.xml><?xml version="1.0" encoding="utf-8"?>
-<p:sld xmlns:a="http://schemas.openxmlformats.org/drawingml/2006/main" xmlns:p="http://schemas.openxmlformats.org/presentationml/2006/main" xmlns:r="http://schemas.openxmlformats.org/officeDocument/2006/relationships">
+<p:sld xmlns:a="http://schemas.openxmlformats.org/drawingml/2006/main" xmlns:r="http://schemas.openxmlformats.org/officeDocument/2006/relationships" xmlns:p="http://schemas.openxmlformats.org/presentationml/2006/main">
   <p:cSld>
     <p:bg>
       <p:bgPr>
@@ -9470,7 +9790,14 @@
         <p:cNvGrpSpPr/>
         <p:nvPr/>
       </p:nvGrpSpPr>
-      <p:grpSpPr/>
+      <p:grpSpPr>
+        <a:xfrm>
+          <a:off x="0" y="0"/>
+          <a:ext cx="0" cy="0"/>
+          <a:chOff x="0" y="0"/>
+          <a:chExt cx="0" cy="0"/>
+        </a:xfrm>
+      </p:grpSpPr>
       <p:sp>
         <p:nvSpPr>
           <p:cNvPr id="2" name="TextBox 1"/>
@@ -9547,6 +9874,7 @@
           <a:lstStyle/>
           <a:p>
             <a:pPr algn="ctr"/>
+            <a:endParaRPr/>
           </a:p>
         </p:txBody>
       </p:sp>
@@ -9569,13 +9897,55 @@
                 <a:tableStyleId>{5C22544A-7EE6-4342-B048-85BDC9FD1C3A}</a:tableStyleId>
               </a:tblPr>
               <a:tblGrid>
-                <a:gridCol w="1528354"/>
-                <a:gridCol w="1528354"/>
-                <a:gridCol w="1528354"/>
-                <a:gridCol w="1528354"/>
-                <a:gridCol w="1528354"/>
-                <a:gridCol w="1528354"/>
-                <a:gridCol w="1528356"/>
+                <a:gridCol w="1528354">
+                  <a:extLst>
+                    <a:ext uri="{9D8B030D-6E8A-4147-A177-3AD203B41FA5}">
+                      <a16:colId xmlns:a16="http://schemas.microsoft.com/office/drawing/2014/main" val="20000"/>
+                    </a:ext>
+                  </a:extLst>
+                </a:gridCol>
+                <a:gridCol w="1528354">
+                  <a:extLst>
+                    <a:ext uri="{9D8B030D-6E8A-4147-A177-3AD203B41FA5}">
+                      <a16:colId xmlns:a16="http://schemas.microsoft.com/office/drawing/2014/main" val="20001"/>
+                    </a:ext>
+                  </a:extLst>
+                </a:gridCol>
+                <a:gridCol w="1528354">
+                  <a:extLst>
+                    <a:ext uri="{9D8B030D-6E8A-4147-A177-3AD203B41FA5}">
+                      <a16:colId xmlns:a16="http://schemas.microsoft.com/office/drawing/2014/main" val="20002"/>
+                    </a:ext>
+                  </a:extLst>
+                </a:gridCol>
+                <a:gridCol w="1528354">
+                  <a:extLst>
+                    <a:ext uri="{9D8B030D-6E8A-4147-A177-3AD203B41FA5}">
+                      <a16:colId xmlns:a16="http://schemas.microsoft.com/office/drawing/2014/main" val="20003"/>
+                    </a:ext>
+                  </a:extLst>
+                </a:gridCol>
+                <a:gridCol w="1528354">
+                  <a:extLst>
+                    <a:ext uri="{9D8B030D-6E8A-4147-A177-3AD203B41FA5}">
+                      <a16:colId xmlns:a16="http://schemas.microsoft.com/office/drawing/2014/main" val="20004"/>
+                    </a:ext>
+                  </a:extLst>
+                </a:gridCol>
+                <a:gridCol w="1528354">
+                  <a:extLst>
+                    <a:ext uri="{9D8B030D-6E8A-4147-A177-3AD203B41FA5}">
+                      <a16:colId xmlns:a16="http://schemas.microsoft.com/office/drawing/2014/main" val="20005"/>
+                    </a:ext>
+                  </a:extLst>
+                </a:gridCol>
+                <a:gridCol w="1528356">
+                  <a:extLst>
+                    <a:ext uri="{9D8B030D-6E8A-4147-A177-3AD203B41FA5}">
+                      <a16:colId xmlns:a16="http://schemas.microsoft.com/office/drawing/2014/main" val="20006"/>
+                    </a:ext>
+                  </a:extLst>
+                </a:gridCol>
               </a:tblGrid>
               <a:tr h="512064">
                 <a:tc>
@@ -9746,6 +10116,11 @@
                     </a:solidFill>
                   </a:tcPr>
                 </a:tc>
+                <a:extLst>
+                  <a:ext uri="{0D108BD9-81ED-4DB2-BD59-A6C34878D82A}">
+                    <a16:rowId xmlns:a16="http://schemas.microsoft.com/office/drawing/2014/main" val="10000"/>
+                  </a:ext>
+                </a:extLst>
               </a:tr>
               <a:tr h="512064">
                 <a:tc>
@@ -9916,6 +10291,11 @@
                     </a:solidFill>
                   </a:tcPr>
                 </a:tc>
+                <a:extLst>
+                  <a:ext uri="{0D108BD9-81ED-4DB2-BD59-A6C34878D82A}">
+                    <a16:rowId xmlns:a16="http://schemas.microsoft.com/office/drawing/2014/main" val="10001"/>
+                  </a:ext>
+                </a:extLst>
               </a:tr>
               <a:tr h="512064">
                 <a:tc>
@@ -10086,6 +10466,11 @@
                     </a:solidFill>
                   </a:tcPr>
                 </a:tc>
+                <a:extLst>
+                  <a:ext uri="{0D108BD9-81ED-4DB2-BD59-A6C34878D82A}">
+                    <a16:rowId xmlns:a16="http://schemas.microsoft.com/office/drawing/2014/main" val="10002"/>
+                  </a:ext>
+                </a:extLst>
               </a:tr>
               <a:tr h="512064">
                 <a:tc>
@@ -10256,6 +10641,11 @@
                     </a:solidFill>
                   </a:tcPr>
                 </a:tc>
+                <a:extLst>
+                  <a:ext uri="{0D108BD9-81ED-4DB2-BD59-A6C34878D82A}">
+                    <a16:rowId xmlns:a16="http://schemas.microsoft.com/office/drawing/2014/main" val="10003"/>
+                  </a:ext>
+                </a:extLst>
               </a:tr>
               <a:tr h="512064">
                 <a:tc>
@@ -10426,6 +10816,11 @@
                     </a:solidFill>
                   </a:tcPr>
                 </a:tc>
+                <a:extLst>
+                  <a:ext uri="{0D108BD9-81ED-4DB2-BD59-A6C34878D82A}">
+                    <a16:rowId xmlns:a16="http://schemas.microsoft.com/office/drawing/2014/main" val="10004"/>
+                  </a:ext>
+                </a:extLst>
               </a:tr>
             </a:tbl>
           </a:graphicData>
@@ -10480,6 +10875,7 @@
                 <a:latin typeface="Calibri"/>
               </a:defRPr>
             </a:pPr>
+            <a:endParaRPr/>
           </a:p>
           <a:p>
             <a:pPr>

</xml_diff>